<commit_message>
Update PowerPoint for song #5 in FUBC - English
</commit_message>
<xml_diff>
--- a/fubc-en/5-My Worth Is Not In What I Own.pptx
+++ b/fubc-en/5-My Worth Is Not In What I Own.pptx
@@ -2444,23 +2444,6 @@
             </a:r>
             <a:endParaRPr lang="en-US" sz="4000" dirty="0"/>
           </a:p>
-          <a:p>
-            <a:pPr algn="ctr" indent="0" marL="0">
-              <a:buNone/>
-            </a:pPr>
-            <a:r>
-              <a:rPr lang="en-US" sz="4000" b="1" i="1" dirty="0">
-                <a:solidFill>
-                  <a:srgbClr val="FFFFFF"/>
-                </a:solidFill>
-                <a:latin typeface="Arial" pitchFamily="34" charset="0"/>
-                <a:ea typeface="Arial" pitchFamily="34" charset="-122"/>
-                <a:cs typeface="Arial" pitchFamily="34" charset="-120"/>
-              </a:rPr>
-              <a:t>I rejoice in my Redeemer,</a:t>
-            </a:r>
-            <a:endParaRPr lang="en-US" sz="4000" dirty="0"/>
-          </a:p>
         </p:txBody>
       </p:sp>
     </p:spTree>
@@ -2528,6 +2511,23 @@
                 <a:ea typeface="Arial" pitchFamily="34" charset="-122"/>
                 <a:cs typeface="Arial" pitchFamily="34" charset="-120"/>
               </a:rPr>
+              <a:t>I rejoice in my Redeemer,</a:t>
+            </a:r>
+            <a:endParaRPr lang="en-US" sz="4000" dirty="0"/>
+          </a:p>
+          <a:p>
+            <a:pPr algn="ctr" indent="0" marL="0">
+              <a:buNone/>
+            </a:pPr>
+            <a:r>
+              <a:rPr lang="en-US" sz="4000" b="1" i="1" dirty="0">
+                <a:solidFill>
+                  <a:srgbClr val="FFFFFF"/>
+                </a:solidFill>
+                <a:latin typeface="Arial" pitchFamily="34" charset="0"/>
+                <a:ea typeface="Arial" pitchFamily="34" charset="-122"/>
+                <a:cs typeface="Arial" pitchFamily="34" charset="-120"/>
+              </a:rPr>
               <a:t>Greatest Treasure, Wellspring of my soul.</a:t>
             </a:r>
             <a:endParaRPr lang="en-US" sz="4000" dirty="0"/>
@@ -2562,7 +2562,7 @@
                 <a:ea typeface="Arial" pitchFamily="34" charset="-122"/>
                 <a:cs typeface="Arial" pitchFamily="34" charset="-120"/>
               </a:rPr>
-              <a:t>my soul is satisfied in Him alone.</a:t>
+              <a:t>My soul is satisfied in Him alone.</a:t>
             </a:r>
             <a:endParaRPr lang="en-US" sz="4000" dirty="0"/>
           </a:p>

</xml_diff>

<commit_message>
Regenerate PowerPoint for song #5 in fubc-en
</commit_message>
<xml_diff>
--- a/fubc-en/5-My Worth Is Not In What I Own.pptx
+++ b/fubc-en/5-My Worth Is Not In What I Own.pptx
@@ -14,9 +14,10 @@
     <p:sldId id="262" r:id="rId8"/>
     <p:sldId id="263" r:id="rId9"/>
     <p:sldId id="264" r:id="rId10"/>
+    <p:sldId id="265" r:id="rId11"/>
   </p:sldIdLst>
   <p:notesMasterIdLst>
-    <p:notesMasterId r:id="rId11"/>
+    <p:notesMasterId r:id="rId12"/>
   </p:notesMasterIdLst>
   <p:sldSz cx="12192000" cy="6858000"/>
   <p:notesSz cx="6858000" cy="12192000"/>
@@ -534,6 +535,94 @@
             <a:fld id="{F7021451-1387-4CA6-816F-3879F97B5CBC}" type="slidenum">
               <a:rPr lang="en-US"/>
               <a:t>1</a:t>
+            </a:fld>
+            <a:endParaRPr lang="en-US"/>
+          </a:p>
+        </p:txBody>
+      </p:sp>
+    </p:spTree>
+    <p:extLst>
+      <p:ext uri="{BB962C8B-B14F-4D97-AF65-F5344CB8AC3E}">
+        <p14:creationId xmlns:p14="http://schemas.microsoft.com/office/powerpoint/2010/main" val="1024086991"/>
+      </p:ext>
+    </p:extLst>
+  </p:cSld>
+  <p:clrMapOvr>
+    <a:masterClrMapping/>
+  </p:clrMapOvr>
+</p:notes>
+</file>
+
+<file path=ppt/notesSlides/notesSlide10.xml><?xml version="1.0" encoding="utf-8"?>
+<p:notes xmlns:a="http://schemas.openxmlformats.org/drawingml/2006/main" xmlns:r="http://schemas.openxmlformats.org/officeDocument/2006/relationships" xmlns:p="http://schemas.openxmlformats.org/presentationml/2006/main">
+  <p:cSld>
+    <p:spTree>
+      <p:nvGrpSpPr>
+        <p:cNvPr id="1" name=""/>
+        <p:cNvGrpSpPr/>
+        <p:nvPr/>
+      </p:nvGrpSpPr>
+      <p:grpSpPr>
+        <a:xfrm>
+          <a:off x="0" y="0"/>
+          <a:ext cx="0" cy="0"/>
+          <a:chOff x="0" y="0"/>
+          <a:chExt cx="0" cy="0"/>
+        </a:xfrm>
+      </p:grpSpPr>
+      <p:sp>
+        <p:nvSpPr>
+          <p:cNvPr id="2" name="Slide Image Placeholder 1"/>
+          <p:cNvSpPr>
+            <a:spLocks noGrp="1" noRot="1" noChangeAspect="1"/>
+          </p:cNvSpPr>
+          <p:nvPr>
+            <p:ph type="sldImg"/>
+          </p:nvPr>
+        </p:nvSpPr>
+        <p:spPr/>
+      </p:sp>
+      <p:sp>
+        <p:nvSpPr>
+          <p:cNvPr id="3" name="Notes Placeholder 2"/>
+          <p:cNvSpPr>
+            <a:spLocks noGrp="1"/>
+          </p:cNvSpPr>
+          <p:nvPr>
+            <p:ph type="body" idx="1"/>
+          </p:nvPr>
+        </p:nvSpPr>
+        <p:spPr/>
+        <p:txBody>
+          <a:bodyPr/>
+          <a:lstStyle/>
+          <a:p>
+            <a:r>
+              <a:rPr lang="en-US" dirty="0"/>
+              <a:t/>
+            </a:r>
+            <a:endParaRPr lang="en-US" dirty="0"/>
+          </a:p>
+        </p:txBody>
+      </p:sp>
+      <p:sp>
+        <p:nvSpPr>
+          <p:cNvPr id="4" name="Slide Number Placeholder 3"/>
+          <p:cNvSpPr>
+            <a:spLocks noGrp="1"/>
+          </p:cNvSpPr>
+          <p:nvPr>
+            <p:ph type="sldNum" sz="quarter" idx="10"/>
+          </p:nvPr>
+        </p:nvSpPr>
+        <p:spPr/>
+        <p:txBody>
+          <a:bodyPr/>
+          <a:lstStyle/>
+          <a:p>
+            <a:fld id="{F7021451-1387-4CA6-816F-3879F97B5CBC}" type="slidenum">
+              <a:rPr lang="en-US"/>
+              <a:t>10</a:t>
             </a:fld>
             <a:endParaRPr lang="en-US"/>
           </a:p>
@@ -1612,51 +1701,173 @@
               <a:buNone/>
             </a:pPr>
             <a:r>
-              <a:rPr lang="en-US" sz="4000" b="1" dirty="0">
-                <a:solidFill>
-                  <a:srgbClr val="FFFFFF"/>
-                </a:solidFill>
-                <a:latin typeface="Arial" pitchFamily="34" charset="0"/>
-                <a:ea typeface="Arial" pitchFamily="34" charset="-122"/>
-                <a:cs typeface="Arial" pitchFamily="34" charset="-120"/>
-              </a:rPr>
-              <a:t>My worth is not in what I own,</a:t>
-            </a:r>
-            <a:endParaRPr lang="en-US" sz="4000" dirty="0"/>
-          </a:p>
-          <a:p>
-            <a:pPr algn="ctr" indent="0" marL="0">
-              <a:buNone/>
-            </a:pPr>
-            <a:r>
-              <a:rPr lang="en-US" sz="4000" b="1" dirty="0">
-                <a:solidFill>
-                  <a:srgbClr val="FFFFFF"/>
-                </a:solidFill>
-                <a:latin typeface="Arial" pitchFamily="34" charset="0"/>
-                <a:ea typeface="Arial" pitchFamily="34" charset="-122"/>
-                <a:cs typeface="Arial" pitchFamily="34" charset="-120"/>
-              </a:rPr>
-              <a:t>not in the strength of flesh and bone.</a:t>
-            </a:r>
-            <a:endParaRPr lang="en-US" sz="4000" dirty="0"/>
-          </a:p>
-          <a:p>
-            <a:pPr algn="ctr" indent="0" marL="0">
-              <a:buNone/>
-            </a:pPr>
-            <a:r>
-              <a:rPr lang="en-US" sz="4000" b="1" dirty="0">
-                <a:solidFill>
-                  <a:srgbClr val="FFFFFF"/>
-                </a:solidFill>
-                <a:latin typeface="Arial" pitchFamily="34" charset="0"/>
-                <a:ea typeface="Arial" pitchFamily="34" charset="-122"/>
-                <a:cs typeface="Arial" pitchFamily="34" charset="-120"/>
-              </a:rPr>
-              <a:t>But in the costly wounds of love, at the cross.</a:t>
-            </a:r>
-            <a:endParaRPr lang="en-US" sz="4000" dirty="0"/>
+              <a:rPr lang="en-US" sz="4800" b="1" dirty="0">
+                <a:solidFill>
+                  <a:srgbClr val="FFFFFF"/>
+                </a:solidFill>
+                <a:latin typeface="Arial" pitchFamily="34" charset="0"/>
+                <a:ea typeface="Arial" pitchFamily="34" charset="-122"/>
+                <a:cs typeface="Arial" pitchFamily="34" charset="-120"/>
+              </a:rPr>
+              <a:t>My Worth Is Not In What I Own</a:t>
+            </a:r>
+            <a:endParaRPr lang="en-US" sz="4800" dirty="0"/>
+          </a:p>
+        </p:txBody>
+      </p:sp>
+    </p:spTree>
+  </p:cSld>
+  <p:clrMapOvr>
+    <a:masterClrMapping/>
+  </p:clrMapOvr>
+</p:sld>
+</file>
+
+<file path=ppt/slides/slide10.xml><?xml version="1.0" encoding="utf-8"?>
+<p:sld xmlns:a="http://schemas.openxmlformats.org/drawingml/2006/main" xmlns:r="http://schemas.openxmlformats.org/officeDocument/2006/relationships" xmlns:p="http://schemas.openxmlformats.org/presentationml/2006/main">
+  <p:cSld name="Slide 10">
+    <p:bg>
+      <p:bgPr>
+        <a:solidFill>
+          <a:srgbClr val="000000"/>
+        </a:solidFill>
+      </p:bgPr>
+    </p:bg>
+    <p:spTree>
+      <p:nvGrpSpPr>
+        <p:cNvPr id="1" name=""/>
+        <p:cNvGrpSpPr/>
+        <p:nvPr/>
+      </p:nvGrpSpPr>
+      <p:grpSpPr>
+        <a:xfrm>
+          <a:off x="0" y="0"/>
+          <a:ext cx="0" cy="0"/>
+          <a:chOff x="0" y="0"/>
+          <a:chExt cx="0" cy="0"/>
+        </a:xfrm>
+      </p:grpSpPr>
+      <p:sp>
+        <p:nvSpPr>
+          <p:cNvPr id="2" name="Text 0"/>
+          <p:cNvSpPr txBox="1"/>
+          <p:nvPr/>
+        </p:nvSpPr>
+        <p:spPr>
+          <a:xfrm>
+            <a:off x="548640" y="457200"/>
+            <a:ext cx="11064240" cy="5943600"/>
+          </a:xfrm>
+          <a:prstGeom prst="rect">
+            <a:avLst/>
+          </a:prstGeom>
+          <a:noFill/>
+          <a:ln/>
+        </p:spPr>
+        <p:txBody>
+          <a:bodyPr wrap="square" lIns="0" tIns="0" rIns="0" bIns="0" rtlCol="0" anchor="ctr"/>
+          <a:lstStyle/>
+          <a:p>
+            <a:pPr algn="ctr" indent="0" marL="0">
+              <a:buNone/>
+            </a:pPr>
+            <a:r>
+              <a:rPr lang="en-US" sz="4800" b="1" i="1" dirty="0">
+                <a:solidFill>
+                  <a:srgbClr val="FFFFFF"/>
+                </a:solidFill>
+                <a:latin typeface="Arial" pitchFamily="34" charset="0"/>
+                <a:ea typeface="Arial" pitchFamily="34" charset="-122"/>
+                <a:cs typeface="Arial" pitchFamily="34" charset="-120"/>
+              </a:rPr>
+              <a:t>I rejoice in my Redeemer,</a:t>
+            </a:r>
+            <a:endParaRPr lang="en-US" sz="4800" dirty="0"/>
+          </a:p>
+          <a:p>
+            <a:pPr algn="ctr" indent="0" marL="0">
+              <a:buNone/>
+            </a:pPr>
+            <a:r>
+              <a:rPr lang="en-US" sz="4800" b="1" i="1" dirty="0">
+                <a:solidFill>
+                  <a:srgbClr val="FFFFFF"/>
+                </a:solidFill>
+                <a:latin typeface="Arial" pitchFamily="34" charset="0"/>
+                <a:ea typeface="Arial" pitchFamily="34" charset="-122"/>
+                <a:cs typeface="Arial" pitchFamily="34" charset="-120"/>
+              </a:rPr>
+              <a:t>Greatest Treasure, Wellspring of my soul.</a:t>
+            </a:r>
+            <a:endParaRPr lang="en-US" sz="4800" dirty="0"/>
+          </a:p>
+          <a:p>
+            <a:pPr algn="ctr" indent="0" marL="0">
+              <a:buNone/>
+            </a:pPr>
+            <a:r>
+              <a:rPr lang="en-US" sz="4800" b="1" i="1" dirty="0">
+                <a:solidFill>
+                  <a:srgbClr val="FFFFFF"/>
+                </a:solidFill>
+                <a:latin typeface="Arial" pitchFamily="34" charset="0"/>
+                <a:ea typeface="Arial" pitchFamily="34" charset="-122"/>
+                <a:cs typeface="Arial" pitchFamily="34" charset="-120"/>
+              </a:rPr>
+              <a:t>I will trust in Him, no other,</a:t>
+            </a:r>
+            <a:endParaRPr lang="en-US" sz="4800" dirty="0"/>
+          </a:p>
+          <a:p>
+            <a:pPr algn="ctr" indent="0" marL="0">
+              <a:buNone/>
+            </a:pPr>
+            <a:r>
+              <a:rPr lang="en-US" sz="4800" b="1" i="1" dirty="0">
+                <a:solidFill>
+                  <a:srgbClr val="FFFFFF"/>
+                </a:solidFill>
+                <a:latin typeface="Arial" pitchFamily="34" charset="0"/>
+                <a:ea typeface="Arial" pitchFamily="34" charset="-122"/>
+                <a:cs typeface="Arial" pitchFamily="34" charset="-120"/>
+              </a:rPr>
+              <a:t>My soul is satisfied in Him alone.</a:t>
+            </a:r>
+            <a:endParaRPr lang="en-US" sz="4800" dirty="0"/>
+          </a:p>
+          <a:p>
+            <a:pPr algn="ctr" indent="0" marL="0">
+              <a:buNone/>
+            </a:pPr>
+            <a:r>
+              <a:rPr lang="en-US" sz="4800" b="1" i="1" dirty="0">
+                <a:solidFill>
+                  <a:srgbClr val="FFFFFF"/>
+                </a:solidFill>
+                <a:latin typeface="Arial" pitchFamily="34" charset="0"/>
+                <a:ea typeface="Arial" pitchFamily="34" charset="-122"/>
+                <a:cs typeface="Arial" pitchFamily="34" charset="-120"/>
+              </a:rPr>
+              <a:t>My soul is satisfied in Him alone.</a:t>
+            </a:r>
+            <a:endParaRPr lang="en-US" sz="4800" dirty="0"/>
+          </a:p>
+          <a:p>
+            <a:pPr algn="ctr" indent="0" marL="0">
+              <a:buNone/>
+            </a:pPr>
+            <a:r>
+              <a:rPr lang="en-US" sz="4800" b="1" i="1" dirty="0">
+                <a:solidFill>
+                  <a:srgbClr val="FFFFFF"/>
+                </a:solidFill>
+                <a:latin typeface="Arial" pitchFamily="34" charset="0"/>
+                <a:ea typeface="Arial" pitchFamily="34" charset="-122"/>
+                <a:cs typeface="Arial" pitchFamily="34" charset="-120"/>
+              </a:rPr>
+              <a:t>***</a:t>
+            </a:r>
+            <a:endParaRPr lang="en-US" sz="4800" dirty="0"/>
           </a:p>
         </p:txBody>
       </p:sp>
@@ -1717,51 +1928,51 @@
               <a:buNone/>
             </a:pPr>
             <a:r>
-              <a:rPr lang="en-US" sz="4000" b="1" dirty="0">
-                <a:solidFill>
-                  <a:srgbClr val="FFFFFF"/>
-                </a:solidFill>
-                <a:latin typeface="Arial" pitchFamily="34" charset="0"/>
-                <a:ea typeface="Arial" pitchFamily="34" charset="-122"/>
-                <a:cs typeface="Arial" pitchFamily="34" charset="-120"/>
-              </a:rPr>
-              <a:t>My worth is not in skill or name,</a:t>
-            </a:r>
-            <a:endParaRPr lang="en-US" sz="4000" dirty="0"/>
-          </a:p>
-          <a:p>
-            <a:pPr algn="ctr" indent="0" marL="0">
-              <a:buNone/>
-            </a:pPr>
-            <a:r>
-              <a:rPr lang="en-US" sz="4000" b="1" dirty="0">
-                <a:solidFill>
-                  <a:srgbClr val="FFFFFF"/>
-                </a:solidFill>
-                <a:latin typeface="Arial" pitchFamily="34" charset="0"/>
-                <a:ea typeface="Arial" pitchFamily="34" charset="-122"/>
-                <a:cs typeface="Arial" pitchFamily="34" charset="-120"/>
-              </a:rPr>
-              <a:t>in win or lose, in pride or shame.</a:t>
-            </a:r>
-            <a:endParaRPr lang="en-US" sz="4000" dirty="0"/>
-          </a:p>
-          <a:p>
-            <a:pPr algn="ctr" indent="0" marL="0">
-              <a:buNone/>
-            </a:pPr>
-            <a:r>
-              <a:rPr lang="en-US" sz="4000" b="1" dirty="0">
-                <a:solidFill>
-                  <a:srgbClr val="FFFFFF"/>
-                </a:solidFill>
-                <a:latin typeface="Arial" pitchFamily="34" charset="0"/>
-                <a:ea typeface="Arial" pitchFamily="34" charset="-122"/>
-                <a:cs typeface="Arial" pitchFamily="34" charset="-120"/>
-              </a:rPr>
-              <a:t>But in the blood of Christ that flowed at the cross.</a:t>
-            </a:r>
-            <a:endParaRPr lang="en-US" sz="4000" dirty="0"/>
+              <a:rPr lang="en-US" sz="4800" b="1" dirty="0">
+                <a:solidFill>
+                  <a:srgbClr val="FFFFFF"/>
+                </a:solidFill>
+                <a:latin typeface="Arial" pitchFamily="34" charset="0"/>
+                <a:ea typeface="Arial" pitchFamily="34" charset="-122"/>
+                <a:cs typeface="Arial" pitchFamily="34" charset="-120"/>
+              </a:rPr>
+              <a:t>My worth is not in what I own,</a:t>
+            </a:r>
+            <a:endParaRPr lang="en-US" sz="4800" dirty="0"/>
+          </a:p>
+          <a:p>
+            <a:pPr algn="ctr" indent="0" marL="0">
+              <a:buNone/>
+            </a:pPr>
+            <a:r>
+              <a:rPr lang="en-US" sz="4800" b="1" dirty="0">
+                <a:solidFill>
+                  <a:srgbClr val="FFFFFF"/>
+                </a:solidFill>
+                <a:latin typeface="Arial" pitchFamily="34" charset="0"/>
+                <a:ea typeface="Arial" pitchFamily="34" charset="-122"/>
+                <a:cs typeface="Arial" pitchFamily="34" charset="-120"/>
+              </a:rPr>
+              <a:t>not in the strength of flesh and bone.</a:t>
+            </a:r>
+            <a:endParaRPr lang="en-US" sz="4800" dirty="0"/>
+          </a:p>
+          <a:p>
+            <a:pPr algn="ctr" indent="0" marL="0">
+              <a:buNone/>
+            </a:pPr>
+            <a:r>
+              <a:rPr lang="en-US" sz="4800" b="1" dirty="0">
+                <a:solidFill>
+                  <a:srgbClr val="FFFFFF"/>
+                </a:solidFill>
+                <a:latin typeface="Arial" pitchFamily="34" charset="0"/>
+                <a:ea typeface="Arial" pitchFamily="34" charset="-122"/>
+                <a:cs typeface="Arial" pitchFamily="34" charset="-120"/>
+              </a:rPr>
+              <a:t>But in the costly wounds of love, at the cross.</a:t>
+            </a:r>
+            <a:endParaRPr lang="en-US" sz="4800" dirty="0"/>
           </a:p>
         </p:txBody>
       </p:sp>
@@ -1822,68 +2033,51 @@
               <a:buNone/>
             </a:pPr>
             <a:r>
-              <a:rPr lang="en-US" sz="4000" b="1" i="1" dirty="0">
-                <a:solidFill>
-                  <a:srgbClr val="FFFFFF"/>
-                </a:solidFill>
-                <a:latin typeface="Arial" pitchFamily="34" charset="0"/>
-                <a:ea typeface="Arial" pitchFamily="34" charset="-122"/>
-                <a:cs typeface="Arial" pitchFamily="34" charset="-120"/>
-              </a:rPr>
-              <a:t>I rejoice in my Redeemer,</a:t>
-            </a:r>
-            <a:endParaRPr lang="en-US" sz="4000" dirty="0"/>
-          </a:p>
-          <a:p>
-            <a:pPr algn="ctr" indent="0" marL="0">
-              <a:buNone/>
-            </a:pPr>
-            <a:r>
-              <a:rPr lang="en-US" sz="4000" b="1" i="1" dirty="0">
-                <a:solidFill>
-                  <a:srgbClr val="FFFFFF"/>
-                </a:solidFill>
-                <a:latin typeface="Arial" pitchFamily="34" charset="0"/>
-                <a:ea typeface="Arial" pitchFamily="34" charset="-122"/>
-                <a:cs typeface="Arial" pitchFamily="34" charset="-120"/>
-              </a:rPr>
-              <a:t>Greatest Treasure, Wellspring of my soul.</a:t>
-            </a:r>
-            <a:endParaRPr lang="en-US" sz="4000" dirty="0"/>
-          </a:p>
-          <a:p>
-            <a:pPr algn="ctr" indent="0" marL="0">
-              <a:buNone/>
-            </a:pPr>
-            <a:r>
-              <a:rPr lang="en-US" sz="4000" b="1" i="1" dirty="0">
-                <a:solidFill>
-                  <a:srgbClr val="FFFFFF"/>
-                </a:solidFill>
-                <a:latin typeface="Arial" pitchFamily="34" charset="0"/>
-                <a:ea typeface="Arial" pitchFamily="34" charset="-122"/>
-                <a:cs typeface="Arial" pitchFamily="34" charset="-120"/>
-              </a:rPr>
-              <a:t>I will trust in Him, no other,</a:t>
-            </a:r>
-            <a:endParaRPr lang="en-US" sz="4000" dirty="0"/>
-          </a:p>
-          <a:p>
-            <a:pPr algn="ctr" indent="0" marL="0">
-              <a:buNone/>
-            </a:pPr>
-            <a:r>
-              <a:rPr lang="en-US" sz="4000" b="1" i="1" dirty="0">
-                <a:solidFill>
-                  <a:srgbClr val="FFFFFF"/>
-                </a:solidFill>
-                <a:latin typeface="Arial" pitchFamily="34" charset="0"/>
-                <a:ea typeface="Arial" pitchFamily="34" charset="-122"/>
-                <a:cs typeface="Arial" pitchFamily="34" charset="-120"/>
-              </a:rPr>
-              <a:t>my soul is satisfied in Him alone.</a:t>
-            </a:r>
-            <a:endParaRPr lang="en-US" sz="4000" dirty="0"/>
+              <a:rPr lang="en-US" sz="4800" b="1" dirty="0">
+                <a:solidFill>
+                  <a:srgbClr val="FFFFFF"/>
+                </a:solidFill>
+                <a:latin typeface="Arial" pitchFamily="34" charset="0"/>
+                <a:ea typeface="Arial" pitchFamily="34" charset="-122"/>
+                <a:cs typeface="Arial" pitchFamily="34" charset="-120"/>
+              </a:rPr>
+              <a:t>My worth is not in skill or name,</a:t>
+            </a:r>
+            <a:endParaRPr lang="en-US" sz="4800" dirty="0"/>
+          </a:p>
+          <a:p>
+            <a:pPr algn="ctr" indent="0" marL="0">
+              <a:buNone/>
+            </a:pPr>
+            <a:r>
+              <a:rPr lang="en-US" sz="4800" b="1" dirty="0">
+                <a:solidFill>
+                  <a:srgbClr val="FFFFFF"/>
+                </a:solidFill>
+                <a:latin typeface="Arial" pitchFamily="34" charset="0"/>
+                <a:ea typeface="Arial" pitchFamily="34" charset="-122"/>
+                <a:cs typeface="Arial" pitchFamily="34" charset="-120"/>
+              </a:rPr>
+              <a:t>in win or lose, in pride or shame.</a:t>
+            </a:r>
+            <a:endParaRPr lang="en-US" sz="4800" dirty="0"/>
+          </a:p>
+          <a:p>
+            <a:pPr algn="ctr" indent="0" marL="0">
+              <a:buNone/>
+            </a:pPr>
+            <a:r>
+              <a:rPr lang="en-US" sz="4800" b="1" dirty="0">
+                <a:solidFill>
+                  <a:srgbClr val="FFFFFF"/>
+                </a:solidFill>
+                <a:latin typeface="Arial" pitchFamily="34" charset="0"/>
+                <a:ea typeface="Arial" pitchFamily="34" charset="-122"/>
+                <a:cs typeface="Arial" pitchFamily="34" charset="-120"/>
+              </a:rPr>
+              <a:t>But in the blood of Christ that flowed at the cross.</a:t>
+            </a:r>
+            <a:endParaRPr lang="en-US" sz="4800" dirty="0"/>
           </a:p>
         </p:txBody>
       </p:sp>
@@ -1944,51 +2138,68 @@
               <a:buNone/>
             </a:pPr>
             <a:r>
-              <a:rPr lang="en-US" sz="4000" b="1" dirty="0">
-                <a:solidFill>
-                  <a:srgbClr val="FFFFFF"/>
-                </a:solidFill>
-                <a:latin typeface="Arial" pitchFamily="34" charset="0"/>
-                <a:ea typeface="Arial" pitchFamily="34" charset="-122"/>
-                <a:cs typeface="Arial" pitchFamily="34" charset="-120"/>
-              </a:rPr>
-              <a:t>As summer flowers we fade and die.</a:t>
-            </a:r>
-            <a:endParaRPr lang="en-US" sz="4000" dirty="0"/>
-          </a:p>
-          <a:p>
-            <a:pPr algn="ctr" indent="0" marL="0">
-              <a:buNone/>
-            </a:pPr>
-            <a:r>
-              <a:rPr lang="en-US" sz="4000" b="1" dirty="0">
-                <a:solidFill>
-                  <a:srgbClr val="FFFFFF"/>
-                </a:solidFill>
-                <a:latin typeface="Arial" pitchFamily="34" charset="0"/>
-                <a:ea typeface="Arial" pitchFamily="34" charset="-122"/>
-                <a:cs typeface="Arial" pitchFamily="34" charset="-120"/>
-              </a:rPr>
-              <a:t>Fame, youth and beauty hurry by.</a:t>
-            </a:r>
-            <a:endParaRPr lang="en-US" sz="4000" dirty="0"/>
-          </a:p>
-          <a:p>
-            <a:pPr algn="ctr" indent="0" marL="0">
-              <a:buNone/>
-            </a:pPr>
-            <a:r>
-              <a:rPr lang="en-US" sz="4000" b="1" dirty="0">
-                <a:solidFill>
-                  <a:srgbClr val="FFFFFF"/>
-                </a:solidFill>
-                <a:latin typeface="Arial" pitchFamily="34" charset="0"/>
-                <a:ea typeface="Arial" pitchFamily="34" charset="-122"/>
-                <a:cs typeface="Arial" pitchFamily="34" charset="-120"/>
-              </a:rPr>
-              <a:t>But life eternal calls to us, at the cross.</a:t>
-            </a:r>
-            <a:endParaRPr lang="en-US" sz="4000" dirty="0"/>
+              <a:rPr lang="en-US" sz="4800" b="1" i="1" dirty="0">
+                <a:solidFill>
+                  <a:srgbClr val="FFFFFF"/>
+                </a:solidFill>
+                <a:latin typeface="Arial" pitchFamily="34" charset="0"/>
+                <a:ea typeface="Arial" pitchFamily="34" charset="-122"/>
+                <a:cs typeface="Arial" pitchFamily="34" charset="-120"/>
+              </a:rPr>
+              <a:t>I rejoice in my Redeemer,</a:t>
+            </a:r>
+            <a:endParaRPr lang="en-US" sz="4800" dirty="0"/>
+          </a:p>
+          <a:p>
+            <a:pPr algn="ctr" indent="0" marL="0">
+              <a:buNone/>
+            </a:pPr>
+            <a:r>
+              <a:rPr lang="en-US" sz="4800" b="1" i="1" dirty="0">
+                <a:solidFill>
+                  <a:srgbClr val="FFFFFF"/>
+                </a:solidFill>
+                <a:latin typeface="Arial" pitchFamily="34" charset="0"/>
+                <a:ea typeface="Arial" pitchFamily="34" charset="-122"/>
+                <a:cs typeface="Arial" pitchFamily="34" charset="-120"/>
+              </a:rPr>
+              <a:t>Greatest Treasure, Wellspring of my soul.</a:t>
+            </a:r>
+            <a:endParaRPr lang="en-US" sz="4800" dirty="0"/>
+          </a:p>
+          <a:p>
+            <a:pPr algn="ctr" indent="0" marL="0">
+              <a:buNone/>
+            </a:pPr>
+            <a:r>
+              <a:rPr lang="en-US" sz="4800" b="1" i="1" dirty="0">
+                <a:solidFill>
+                  <a:srgbClr val="FFFFFF"/>
+                </a:solidFill>
+                <a:latin typeface="Arial" pitchFamily="34" charset="0"/>
+                <a:ea typeface="Arial" pitchFamily="34" charset="-122"/>
+                <a:cs typeface="Arial" pitchFamily="34" charset="-120"/>
+              </a:rPr>
+              <a:t>I will trust in Him, no other,</a:t>
+            </a:r>
+            <a:endParaRPr lang="en-US" sz="4800" dirty="0"/>
+          </a:p>
+          <a:p>
+            <a:pPr algn="ctr" indent="0" marL="0">
+              <a:buNone/>
+            </a:pPr>
+            <a:r>
+              <a:rPr lang="en-US" sz="4800" b="1" i="1" dirty="0">
+                <a:solidFill>
+                  <a:srgbClr val="FFFFFF"/>
+                </a:solidFill>
+                <a:latin typeface="Arial" pitchFamily="34" charset="0"/>
+                <a:ea typeface="Arial" pitchFamily="34" charset="-122"/>
+                <a:cs typeface="Arial" pitchFamily="34" charset="-120"/>
+              </a:rPr>
+              <a:t>my soul is satisfied in Him alone.</a:t>
+            </a:r>
+            <a:endParaRPr lang="en-US" sz="4800" dirty="0"/>
           </a:p>
         </p:txBody>
       </p:sp>
@@ -2049,51 +2260,51 @@
               <a:buNone/>
             </a:pPr>
             <a:r>
-              <a:rPr lang="en-US" sz="4000" b="1" dirty="0">
-                <a:solidFill>
-                  <a:srgbClr val="FFFFFF"/>
-                </a:solidFill>
-                <a:latin typeface="Arial" pitchFamily="34" charset="0"/>
-                <a:ea typeface="Arial" pitchFamily="34" charset="-122"/>
-                <a:cs typeface="Arial" pitchFamily="34" charset="-120"/>
-              </a:rPr>
-              <a:t>I will not boast in wealth or might,</a:t>
-            </a:r>
-            <a:endParaRPr lang="en-US" sz="4000" dirty="0"/>
-          </a:p>
-          <a:p>
-            <a:pPr algn="ctr" indent="0" marL="0">
-              <a:buNone/>
-            </a:pPr>
-            <a:r>
-              <a:rPr lang="en-US" sz="4000" b="1" dirty="0">
-                <a:solidFill>
-                  <a:srgbClr val="FFFFFF"/>
-                </a:solidFill>
-                <a:latin typeface="Arial" pitchFamily="34" charset="0"/>
-                <a:ea typeface="Arial" pitchFamily="34" charset="-122"/>
-                <a:cs typeface="Arial" pitchFamily="34" charset="-120"/>
-              </a:rPr>
-              <a:t>or human wisdom’s fleeting light.</a:t>
-            </a:r>
-            <a:endParaRPr lang="en-US" sz="4000" dirty="0"/>
-          </a:p>
-          <a:p>
-            <a:pPr algn="ctr" indent="0" marL="0">
-              <a:buNone/>
-            </a:pPr>
-            <a:r>
-              <a:rPr lang="en-US" sz="4000" b="1" dirty="0">
-                <a:solidFill>
-                  <a:srgbClr val="FFFFFF"/>
-                </a:solidFill>
-                <a:latin typeface="Arial" pitchFamily="34" charset="0"/>
-                <a:ea typeface="Arial" pitchFamily="34" charset="-122"/>
-                <a:cs typeface="Arial" pitchFamily="34" charset="-120"/>
-              </a:rPr>
-              <a:t>But I will boast in knowing Christ, at the cross.</a:t>
-            </a:r>
-            <a:endParaRPr lang="en-US" sz="4000" dirty="0"/>
+              <a:rPr lang="en-US" sz="4800" b="1" dirty="0">
+                <a:solidFill>
+                  <a:srgbClr val="FFFFFF"/>
+                </a:solidFill>
+                <a:latin typeface="Arial" pitchFamily="34" charset="0"/>
+                <a:ea typeface="Arial" pitchFamily="34" charset="-122"/>
+                <a:cs typeface="Arial" pitchFamily="34" charset="-120"/>
+              </a:rPr>
+              <a:t>As summer flowers we fade and die.</a:t>
+            </a:r>
+            <a:endParaRPr lang="en-US" sz="4800" dirty="0"/>
+          </a:p>
+          <a:p>
+            <a:pPr algn="ctr" indent="0" marL="0">
+              <a:buNone/>
+            </a:pPr>
+            <a:r>
+              <a:rPr lang="en-US" sz="4800" b="1" dirty="0">
+                <a:solidFill>
+                  <a:srgbClr val="FFFFFF"/>
+                </a:solidFill>
+                <a:latin typeface="Arial" pitchFamily="34" charset="0"/>
+                <a:ea typeface="Arial" pitchFamily="34" charset="-122"/>
+                <a:cs typeface="Arial" pitchFamily="34" charset="-120"/>
+              </a:rPr>
+              <a:t>Fame, youth and beauty hurry by.</a:t>
+            </a:r>
+            <a:endParaRPr lang="en-US" sz="4800" dirty="0"/>
+          </a:p>
+          <a:p>
+            <a:pPr algn="ctr" indent="0" marL="0">
+              <a:buNone/>
+            </a:pPr>
+            <a:r>
+              <a:rPr lang="en-US" sz="4800" b="1" dirty="0">
+                <a:solidFill>
+                  <a:srgbClr val="FFFFFF"/>
+                </a:solidFill>
+                <a:latin typeface="Arial" pitchFamily="34" charset="0"/>
+                <a:ea typeface="Arial" pitchFamily="34" charset="-122"/>
+                <a:cs typeface="Arial" pitchFamily="34" charset="-120"/>
+              </a:rPr>
+              <a:t>But life eternal calls to us, at the cross.</a:t>
+            </a:r>
+            <a:endParaRPr lang="en-US" sz="4800" dirty="0"/>
           </a:p>
         </p:txBody>
       </p:sp>
@@ -2154,68 +2365,51 @@
               <a:buNone/>
             </a:pPr>
             <a:r>
-              <a:rPr lang="en-US" sz="4000" b="1" i="1" dirty="0">
-                <a:solidFill>
-                  <a:srgbClr val="FFFFFF"/>
-                </a:solidFill>
-                <a:latin typeface="Arial" pitchFamily="34" charset="0"/>
-                <a:ea typeface="Arial" pitchFamily="34" charset="-122"/>
-                <a:cs typeface="Arial" pitchFamily="34" charset="-120"/>
-              </a:rPr>
-              <a:t>I rejoice in my Redeemer,</a:t>
-            </a:r>
-            <a:endParaRPr lang="en-US" sz="4000" dirty="0"/>
-          </a:p>
-          <a:p>
-            <a:pPr algn="ctr" indent="0" marL="0">
-              <a:buNone/>
-            </a:pPr>
-            <a:r>
-              <a:rPr lang="en-US" sz="4000" b="1" i="1" dirty="0">
-                <a:solidFill>
-                  <a:srgbClr val="FFFFFF"/>
-                </a:solidFill>
-                <a:latin typeface="Arial" pitchFamily="34" charset="0"/>
-                <a:ea typeface="Arial" pitchFamily="34" charset="-122"/>
-                <a:cs typeface="Arial" pitchFamily="34" charset="-120"/>
-              </a:rPr>
-              <a:t>Greatest Treasure, Wellspring of my soul.</a:t>
-            </a:r>
-            <a:endParaRPr lang="en-US" sz="4000" dirty="0"/>
-          </a:p>
-          <a:p>
-            <a:pPr algn="ctr" indent="0" marL="0">
-              <a:buNone/>
-            </a:pPr>
-            <a:r>
-              <a:rPr lang="en-US" sz="4000" b="1" i="1" dirty="0">
-                <a:solidFill>
-                  <a:srgbClr val="FFFFFF"/>
-                </a:solidFill>
-                <a:latin typeface="Arial" pitchFamily="34" charset="0"/>
-                <a:ea typeface="Arial" pitchFamily="34" charset="-122"/>
-                <a:cs typeface="Arial" pitchFamily="34" charset="-120"/>
-              </a:rPr>
-              <a:t>I will trust in Him, no other,</a:t>
-            </a:r>
-            <a:endParaRPr lang="en-US" sz="4000" dirty="0"/>
-          </a:p>
-          <a:p>
-            <a:pPr algn="ctr" indent="0" marL="0">
-              <a:buNone/>
-            </a:pPr>
-            <a:r>
-              <a:rPr lang="en-US" sz="4000" b="1" i="1" dirty="0">
-                <a:solidFill>
-                  <a:srgbClr val="FFFFFF"/>
-                </a:solidFill>
-                <a:latin typeface="Arial" pitchFamily="34" charset="0"/>
-                <a:ea typeface="Arial" pitchFamily="34" charset="-122"/>
-                <a:cs typeface="Arial" pitchFamily="34" charset="-120"/>
-              </a:rPr>
-              <a:t>my soul is satisfied in Him alone.</a:t>
-            </a:r>
-            <a:endParaRPr lang="en-US" sz="4000" dirty="0"/>
+              <a:rPr lang="en-US" sz="4800" b="1" dirty="0">
+                <a:solidFill>
+                  <a:srgbClr val="FFFFFF"/>
+                </a:solidFill>
+                <a:latin typeface="Arial" pitchFamily="34" charset="0"/>
+                <a:ea typeface="Arial" pitchFamily="34" charset="-122"/>
+                <a:cs typeface="Arial" pitchFamily="34" charset="-120"/>
+              </a:rPr>
+              <a:t>I will not boast in wealth or might,</a:t>
+            </a:r>
+            <a:endParaRPr lang="en-US" sz="4800" dirty="0"/>
+          </a:p>
+          <a:p>
+            <a:pPr algn="ctr" indent="0" marL="0">
+              <a:buNone/>
+            </a:pPr>
+            <a:r>
+              <a:rPr lang="en-US" sz="4800" b="1" dirty="0">
+                <a:solidFill>
+                  <a:srgbClr val="FFFFFF"/>
+                </a:solidFill>
+                <a:latin typeface="Arial" pitchFamily="34" charset="0"/>
+                <a:ea typeface="Arial" pitchFamily="34" charset="-122"/>
+                <a:cs typeface="Arial" pitchFamily="34" charset="-120"/>
+              </a:rPr>
+              <a:t>or human wisdom’s fleeting light.</a:t>
+            </a:r>
+            <a:endParaRPr lang="en-US" sz="4800" dirty="0"/>
+          </a:p>
+          <a:p>
+            <a:pPr algn="ctr" indent="0" marL="0">
+              <a:buNone/>
+            </a:pPr>
+            <a:r>
+              <a:rPr lang="en-US" sz="4800" b="1" dirty="0">
+                <a:solidFill>
+                  <a:srgbClr val="FFFFFF"/>
+                </a:solidFill>
+                <a:latin typeface="Arial" pitchFamily="34" charset="0"/>
+                <a:ea typeface="Arial" pitchFamily="34" charset="-122"/>
+                <a:cs typeface="Arial" pitchFamily="34" charset="-120"/>
+              </a:rPr>
+              <a:t>But I will boast in knowing Christ, at the cross.</a:t>
+            </a:r>
+            <a:endParaRPr lang="en-US" sz="4800" dirty="0"/>
           </a:p>
         </p:txBody>
       </p:sp>
@@ -2276,51 +2470,68 @@
               <a:buNone/>
             </a:pPr>
             <a:r>
-              <a:rPr lang="en-US" sz="4000" b="1" dirty="0">
-                <a:solidFill>
-                  <a:srgbClr val="FFFFFF"/>
-                </a:solidFill>
-                <a:latin typeface="Arial" pitchFamily="34" charset="0"/>
-                <a:ea typeface="Arial" pitchFamily="34" charset="-122"/>
-                <a:cs typeface="Arial" pitchFamily="34" charset="-120"/>
-              </a:rPr>
-              <a:t>Two wonders here that I confess:</a:t>
-            </a:r>
-            <a:endParaRPr lang="en-US" sz="4000" dirty="0"/>
-          </a:p>
-          <a:p>
-            <a:pPr algn="ctr" indent="0" marL="0">
-              <a:buNone/>
-            </a:pPr>
-            <a:r>
-              <a:rPr lang="en-US" sz="4000" b="1" dirty="0">
-                <a:solidFill>
-                  <a:srgbClr val="FFFFFF"/>
-                </a:solidFill>
-                <a:latin typeface="Arial" pitchFamily="34" charset="0"/>
-                <a:ea typeface="Arial" pitchFamily="34" charset="-122"/>
-                <a:cs typeface="Arial" pitchFamily="34" charset="-120"/>
-              </a:rPr>
-              <a:t>my worth and my unworthiness.</a:t>
-            </a:r>
-            <a:endParaRPr lang="en-US" sz="4000" dirty="0"/>
-          </a:p>
-          <a:p>
-            <a:pPr algn="ctr" indent="0" marL="0">
-              <a:buNone/>
-            </a:pPr>
-            <a:r>
-              <a:rPr lang="en-US" sz="4000" b="1" dirty="0">
-                <a:solidFill>
-                  <a:srgbClr val="FFFFFF"/>
-                </a:solidFill>
-                <a:latin typeface="Arial" pitchFamily="34" charset="0"/>
-                <a:ea typeface="Arial" pitchFamily="34" charset="-122"/>
-                <a:cs typeface="Arial" pitchFamily="34" charset="-120"/>
-              </a:rPr>
-              <a:t>My value fixed – my ransom paid at the cross.</a:t>
-            </a:r>
-            <a:endParaRPr lang="en-US" sz="4000" dirty="0"/>
+              <a:rPr lang="en-US" sz="4800" b="1" i="1" dirty="0">
+                <a:solidFill>
+                  <a:srgbClr val="FFFFFF"/>
+                </a:solidFill>
+                <a:latin typeface="Arial" pitchFamily="34" charset="0"/>
+                <a:ea typeface="Arial" pitchFamily="34" charset="-122"/>
+                <a:cs typeface="Arial" pitchFamily="34" charset="-120"/>
+              </a:rPr>
+              <a:t>I rejoice in my Redeemer,</a:t>
+            </a:r>
+            <a:endParaRPr lang="en-US" sz="4800" dirty="0"/>
+          </a:p>
+          <a:p>
+            <a:pPr algn="ctr" indent="0" marL="0">
+              <a:buNone/>
+            </a:pPr>
+            <a:r>
+              <a:rPr lang="en-US" sz="4800" b="1" i="1" dirty="0">
+                <a:solidFill>
+                  <a:srgbClr val="FFFFFF"/>
+                </a:solidFill>
+                <a:latin typeface="Arial" pitchFamily="34" charset="0"/>
+                <a:ea typeface="Arial" pitchFamily="34" charset="-122"/>
+                <a:cs typeface="Arial" pitchFamily="34" charset="-120"/>
+              </a:rPr>
+              <a:t>Greatest Treasure, Wellspring of my soul.</a:t>
+            </a:r>
+            <a:endParaRPr lang="en-US" sz="4800" dirty="0"/>
+          </a:p>
+          <a:p>
+            <a:pPr algn="ctr" indent="0" marL="0">
+              <a:buNone/>
+            </a:pPr>
+            <a:r>
+              <a:rPr lang="en-US" sz="4800" b="1" i="1" dirty="0">
+                <a:solidFill>
+                  <a:srgbClr val="FFFFFF"/>
+                </a:solidFill>
+                <a:latin typeface="Arial" pitchFamily="34" charset="0"/>
+                <a:ea typeface="Arial" pitchFamily="34" charset="-122"/>
+                <a:cs typeface="Arial" pitchFamily="34" charset="-120"/>
+              </a:rPr>
+              <a:t>I will trust in Him, no other,</a:t>
+            </a:r>
+            <a:endParaRPr lang="en-US" sz="4800" dirty="0"/>
+          </a:p>
+          <a:p>
+            <a:pPr algn="ctr" indent="0" marL="0">
+              <a:buNone/>
+            </a:pPr>
+            <a:r>
+              <a:rPr lang="en-US" sz="4800" b="1" i="1" dirty="0">
+                <a:solidFill>
+                  <a:srgbClr val="FFFFFF"/>
+                </a:solidFill>
+                <a:latin typeface="Arial" pitchFamily="34" charset="0"/>
+                <a:ea typeface="Arial" pitchFamily="34" charset="-122"/>
+                <a:cs typeface="Arial" pitchFamily="34" charset="-120"/>
+              </a:rPr>
+              <a:t>my soul is satisfied in Him alone.</a:t>
+            </a:r>
+            <a:endParaRPr lang="en-US" sz="4800" dirty="0"/>
           </a:p>
         </p:txBody>
       </p:sp>
@@ -2381,68 +2592,51 @@
               <a:buNone/>
             </a:pPr>
             <a:r>
-              <a:rPr lang="en-US" sz="4000" b="1" i="1" dirty="0">
-                <a:solidFill>
-                  <a:srgbClr val="FFFFFF"/>
-                </a:solidFill>
-                <a:latin typeface="Arial" pitchFamily="34" charset="0"/>
-                <a:ea typeface="Arial" pitchFamily="34" charset="-122"/>
-                <a:cs typeface="Arial" pitchFamily="34" charset="-120"/>
-              </a:rPr>
-              <a:t>I rejoice in my Redeemer,</a:t>
-            </a:r>
-            <a:endParaRPr lang="en-US" sz="4000" dirty="0"/>
-          </a:p>
-          <a:p>
-            <a:pPr algn="ctr" indent="0" marL="0">
-              <a:buNone/>
-            </a:pPr>
-            <a:r>
-              <a:rPr lang="en-US" sz="4000" b="1" i="1" dirty="0">
-                <a:solidFill>
-                  <a:srgbClr val="FFFFFF"/>
-                </a:solidFill>
-                <a:latin typeface="Arial" pitchFamily="34" charset="0"/>
-                <a:ea typeface="Arial" pitchFamily="34" charset="-122"/>
-                <a:cs typeface="Arial" pitchFamily="34" charset="-120"/>
-              </a:rPr>
-              <a:t>Greatest Treasure, Wellspring of my soul.</a:t>
-            </a:r>
-            <a:endParaRPr lang="en-US" sz="4000" dirty="0"/>
-          </a:p>
-          <a:p>
-            <a:pPr algn="ctr" indent="0" marL="0">
-              <a:buNone/>
-            </a:pPr>
-            <a:r>
-              <a:rPr lang="en-US" sz="4000" b="1" i="1" dirty="0">
-                <a:solidFill>
-                  <a:srgbClr val="FFFFFF"/>
-                </a:solidFill>
-                <a:latin typeface="Arial" pitchFamily="34" charset="0"/>
-                <a:ea typeface="Arial" pitchFamily="34" charset="-122"/>
-                <a:cs typeface="Arial" pitchFamily="34" charset="-120"/>
-              </a:rPr>
-              <a:t>I will trust in Him, no other,</a:t>
-            </a:r>
-            <a:endParaRPr lang="en-US" sz="4000" dirty="0"/>
-          </a:p>
-          <a:p>
-            <a:pPr algn="ctr" indent="0" marL="0">
-              <a:buNone/>
-            </a:pPr>
-            <a:r>
-              <a:rPr lang="en-US" sz="4000" b="1" i="1" dirty="0">
-                <a:solidFill>
-                  <a:srgbClr val="FFFFFF"/>
-                </a:solidFill>
-                <a:latin typeface="Arial" pitchFamily="34" charset="0"/>
-                <a:ea typeface="Arial" pitchFamily="34" charset="-122"/>
-                <a:cs typeface="Arial" pitchFamily="34" charset="-120"/>
-              </a:rPr>
-              <a:t>my soul is satisfied in Him alone.</a:t>
-            </a:r>
-            <a:endParaRPr lang="en-US" sz="4000" dirty="0"/>
+              <a:rPr lang="en-US" sz="4800" b="1" dirty="0">
+                <a:solidFill>
+                  <a:srgbClr val="FFFFFF"/>
+                </a:solidFill>
+                <a:latin typeface="Arial" pitchFamily="34" charset="0"/>
+                <a:ea typeface="Arial" pitchFamily="34" charset="-122"/>
+                <a:cs typeface="Arial" pitchFamily="34" charset="-120"/>
+              </a:rPr>
+              <a:t>Two wonders here that I confess:</a:t>
+            </a:r>
+            <a:endParaRPr lang="en-US" sz="4800" dirty="0"/>
+          </a:p>
+          <a:p>
+            <a:pPr algn="ctr" indent="0" marL="0">
+              <a:buNone/>
+            </a:pPr>
+            <a:r>
+              <a:rPr lang="en-US" sz="4800" b="1" dirty="0">
+                <a:solidFill>
+                  <a:srgbClr val="FFFFFF"/>
+                </a:solidFill>
+                <a:latin typeface="Arial" pitchFamily="34" charset="0"/>
+                <a:ea typeface="Arial" pitchFamily="34" charset="-122"/>
+                <a:cs typeface="Arial" pitchFamily="34" charset="-120"/>
+              </a:rPr>
+              <a:t>my worth and my unworthiness.</a:t>
+            </a:r>
+            <a:endParaRPr lang="en-US" sz="4800" dirty="0"/>
+          </a:p>
+          <a:p>
+            <a:pPr algn="ctr" indent="0" marL="0">
+              <a:buNone/>
+            </a:pPr>
+            <a:r>
+              <a:rPr lang="en-US" sz="4800" b="1" dirty="0">
+                <a:solidFill>
+                  <a:srgbClr val="FFFFFF"/>
+                </a:solidFill>
+                <a:latin typeface="Arial" pitchFamily="34" charset="0"/>
+                <a:ea typeface="Arial" pitchFamily="34" charset="-122"/>
+                <a:cs typeface="Arial" pitchFamily="34" charset="-120"/>
+              </a:rPr>
+              <a:t>My value fixed – my ransom paid at the cross.</a:t>
+            </a:r>
+            <a:endParaRPr lang="en-US" sz="4800" dirty="0"/>
           </a:p>
         </p:txBody>
       </p:sp>
@@ -2503,7 +2697,7 @@
               <a:buNone/>
             </a:pPr>
             <a:r>
-              <a:rPr lang="en-US" sz="4000" b="1" i="1" dirty="0">
+              <a:rPr lang="en-US" sz="4800" b="1" i="1" dirty="0">
                 <a:solidFill>
                   <a:srgbClr val="FFFFFF"/>
                 </a:solidFill>
@@ -2513,14 +2707,14 @@
               </a:rPr>
               <a:t>I rejoice in my Redeemer,</a:t>
             </a:r>
-            <a:endParaRPr lang="en-US" sz="4000" dirty="0"/>
-          </a:p>
-          <a:p>
-            <a:pPr algn="ctr" indent="0" marL="0">
-              <a:buNone/>
-            </a:pPr>
-            <a:r>
-              <a:rPr lang="en-US" sz="4000" b="1" i="1" dirty="0">
+            <a:endParaRPr lang="en-US" sz="4800" dirty="0"/>
+          </a:p>
+          <a:p>
+            <a:pPr algn="ctr" indent="0" marL="0">
+              <a:buNone/>
+            </a:pPr>
+            <a:r>
+              <a:rPr lang="en-US" sz="4800" b="1" i="1" dirty="0">
                 <a:solidFill>
                   <a:srgbClr val="FFFFFF"/>
                 </a:solidFill>
@@ -2530,14 +2724,14 @@
               </a:rPr>
               <a:t>Greatest Treasure, Wellspring of my soul.</a:t>
             </a:r>
-            <a:endParaRPr lang="en-US" sz="4000" dirty="0"/>
-          </a:p>
-          <a:p>
-            <a:pPr algn="ctr" indent="0" marL="0">
-              <a:buNone/>
-            </a:pPr>
-            <a:r>
-              <a:rPr lang="en-US" sz="4000" b="1" i="1" dirty="0">
+            <a:endParaRPr lang="en-US" sz="4800" dirty="0"/>
+          </a:p>
+          <a:p>
+            <a:pPr algn="ctr" indent="0" marL="0">
+              <a:buNone/>
+            </a:pPr>
+            <a:r>
+              <a:rPr lang="en-US" sz="4800" b="1" i="1" dirty="0">
                 <a:solidFill>
                   <a:srgbClr val="FFFFFF"/>
                 </a:solidFill>
@@ -2547,58 +2741,24 @@
               </a:rPr>
               <a:t>I will trust in Him, no other,</a:t>
             </a:r>
-            <a:endParaRPr lang="en-US" sz="4000" dirty="0"/>
-          </a:p>
-          <a:p>
-            <a:pPr algn="ctr" indent="0" marL="0">
-              <a:buNone/>
-            </a:pPr>
-            <a:r>
-              <a:rPr lang="en-US" sz="4000" b="1" i="1" dirty="0">
-                <a:solidFill>
-                  <a:srgbClr val="FFFFFF"/>
-                </a:solidFill>
-                <a:latin typeface="Arial" pitchFamily="34" charset="0"/>
-                <a:ea typeface="Arial" pitchFamily="34" charset="-122"/>
-                <a:cs typeface="Arial" pitchFamily="34" charset="-120"/>
-              </a:rPr>
-              <a:t>My soul is satisfied in Him alone.</a:t>
-            </a:r>
-            <a:endParaRPr lang="en-US" sz="4000" dirty="0"/>
-          </a:p>
-          <a:p>
-            <a:pPr algn="ctr" indent="0" marL="0">
-              <a:buNone/>
-            </a:pPr>
-            <a:r>
-              <a:rPr lang="en-US" sz="4000" b="1" i="1" dirty="0">
-                <a:solidFill>
-                  <a:srgbClr val="FFFFFF"/>
-                </a:solidFill>
-                <a:latin typeface="Arial" pitchFamily="34" charset="0"/>
-                <a:ea typeface="Arial" pitchFamily="34" charset="-122"/>
-                <a:cs typeface="Arial" pitchFamily="34" charset="-120"/>
-              </a:rPr>
-              <a:t>My soul is satisfied in Him alone.</a:t>
-            </a:r>
-            <a:endParaRPr lang="en-US" sz="4000" dirty="0"/>
-          </a:p>
-          <a:p>
-            <a:pPr algn="ctr" indent="0" marL="0">
-              <a:buNone/>
-            </a:pPr>
-            <a:r>
-              <a:rPr lang="en-US" sz="4000" b="1" i="1" dirty="0">
-                <a:solidFill>
-                  <a:srgbClr val="FFFFFF"/>
-                </a:solidFill>
-                <a:latin typeface="Arial" pitchFamily="34" charset="0"/>
-                <a:ea typeface="Arial" pitchFamily="34" charset="-122"/>
-                <a:cs typeface="Arial" pitchFamily="34" charset="-120"/>
-              </a:rPr>
-              <a:t>***</a:t>
-            </a:r>
-            <a:endParaRPr lang="en-US" sz="4000" dirty="0"/>
+            <a:endParaRPr lang="en-US" sz="4800" dirty="0"/>
+          </a:p>
+          <a:p>
+            <a:pPr algn="ctr" indent="0" marL="0">
+              <a:buNone/>
+            </a:pPr>
+            <a:r>
+              <a:rPr lang="en-US" sz="4800" b="1" i="1" dirty="0">
+                <a:solidFill>
+                  <a:srgbClr val="FFFFFF"/>
+                </a:solidFill>
+                <a:latin typeface="Arial" pitchFamily="34" charset="0"/>
+                <a:ea typeface="Arial" pitchFamily="34" charset="-122"/>
+                <a:cs typeface="Arial" pitchFamily="34" charset="-120"/>
+              </a:rPr>
+              <a:t>my soul is satisfied in Him alone.</a:t>
+            </a:r>
+            <a:endParaRPr lang="en-US" sz="4800" dirty="0"/>
           </a:p>
         </p:txBody>
       </p:sp>

</xml_diff>